<commit_message>
Converte diagrama de empilhamento em imagem para visualizadores móveis
O slide de value stacking usava formas nativas com sombra e seta, que a
pré-visualização do celular renderiza deslocadas. O diagrama de camadas
foi re-renderizado como PNG opaco (SVG rasterizado na paleta da
apresentação), mantendo o visual e garantindo exibição fiel em qualquer
visualizador.

Co-Authored-By: Claude Fable 5 <noreply@anthropic.com>
Claude-Session: https://claude.ai/code/session_0198SeXLUYPhAzabpjaRsyNb
</commit_message>
<xml_diff>
--- a/apresentacoes/BESS_Brasil_Lucas_Silva_Costa.pptx
+++ b/apresentacoes/BESS_Brasil_Lucas_Silva_Costa.pptx
@@ -9501,357 +9501,33 @@
           </a:p>
         </p:txBody>
       </p:sp>
-      <p:sp>
-        <p:nvSpPr>
-          <p:cNvPr id="3" name="Shape 1"/>
-          <p:cNvSpPr/>
-          <p:nvPr/>
-        </p:nvSpPr>
-        <p:spPr>
-          <a:xfrm>
-            <a:off x="685800" y="5138928"/>
-            <a:ext cx="4160520" cy="786384"/>
-          </a:xfrm>
-          <a:prstGeom prst="roundRect">
-            <a:avLst>
-              <a:gd name="adj" fmla="val 6977"/>
-            </a:avLst>
-          </a:prstGeom>
-          <a:solidFill>
-            <a:srgbClr val="31485A"/>
-          </a:solidFill>
-          <a:ln/>
-          <a:effectLst>
-            <a:outerShdw sx="100000" sy="100000" kx="0" ky="0" algn="bl" rotWithShape="0" blurRad="88900" dist="25400" dir="5400000">
-              <a:srgbClr val="9AAAB4">
-                <a:alpha val="35000"/>
-              </a:srgbClr>
-            </a:outerShdw>
-          </a:effectLst>
-        </p:spPr>
-      </p:sp>
-      <p:sp>
-        <p:nvSpPr>
-          <p:cNvPr id="4" name="Text 2"/>
-          <p:cNvSpPr/>
-          <p:nvPr/>
-        </p:nvSpPr>
-        <p:spPr>
-          <a:xfrm>
-            <a:off x="886968" y="5138928"/>
-            <a:ext cx="3758184" cy="786384"/>
-          </a:xfrm>
-          <a:prstGeom prst="rect">
-            <a:avLst/>
-          </a:prstGeom>
-          <a:noFill/>
-          <a:ln/>
-        </p:spPr>
-        <p:txBody>
-          <a:bodyPr wrap="square" lIns="0" tIns="0" rIns="0" bIns="0" rtlCol="0" anchor="ctr"/>
-          <a:lstStyle/>
-          <a:p>
-            <a:pPr indent="0" marL="0">
-              <a:lnSpc>
-                <a:spcPct val="100000"/>
-              </a:lnSpc>
-              <a:buNone/>
-            </a:pPr>
-            <a:r>
-              <a:rPr lang="en-US" sz="1250" b="1" dirty="0">
-                <a:solidFill>
-                  <a:srgbClr val="FFFFFF"/>
-                </a:solidFill>
-                <a:latin typeface="Arial" pitchFamily="34" charset="0"/>
-                <a:ea typeface="Arial" pitchFamily="34" charset="-122"/>
-                <a:cs typeface="Arial" pitchFamily="34" charset="-120"/>
-              </a:rPr>
-              <a:t>Arbitragem tarifária (Time Shifting)</a:t>
-            </a:r>
-            <a:endParaRPr lang="en-US" sz="1250" dirty="0"/>
-          </a:p>
-        </p:txBody>
-      </p:sp>
-      <p:sp>
-        <p:nvSpPr>
-          <p:cNvPr id="5" name="Shape 3"/>
-          <p:cNvSpPr/>
-          <p:nvPr/>
-        </p:nvSpPr>
-        <p:spPr>
-          <a:xfrm>
-            <a:off x="685800" y="4233672"/>
-            <a:ext cx="4160520" cy="786384"/>
-          </a:xfrm>
-          <a:prstGeom prst="roundRect">
-            <a:avLst>
-              <a:gd name="adj" fmla="val 6977"/>
-            </a:avLst>
-          </a:prstGeom>
-          <a:solidFill>
-            <a:srgbClr val="2E7DAF"/>
-          </a:solidFill>
-          <a:ln/>
-          <a:effectLst>
-            <a:outerShdw sx="100000" sy="100000" kx="0" ky="0" algn="bl" rotWithShape="0" blurRad="88900" dist="25400" dir="5400000">
-              <a:srgbClr val="9AAAB4">
-                <a:alpha val="35000"/>
-              </a:srgbClr>
-            </a:outerShdw>
-          </a:effectLst>
-        </p:spPr>
-      </p:sp>
-      <p:sp>
-        <p:nvSpPr>
-          <p:cNvPr id="6" name="Text 4"/>
-          <p:cNvSpPr/>
-          <p:nvPr/>
-        </p:nvSpPr>
-        <p:spPr>
-          <a:xfrm>
-            <a:off x="886968" y="4233672"/>
-            <a:ext cx="3758184" cy="786384"/>
-          </a:xfrm>
-          <a:prstGeom prst="rect">
-            <a:avLst/>
-          </a:prstGeom>
-          <a:noFill/>
-          <a:ln/>
-        </p:spPr>
-        <p:txBody>
-          <a:bodyPr wrap="square" lIns="0" tIns="0" rIns="0" bIns="0" rtlCol="0" anchor="ctr"/>
-          <a:lstStyle/>
-          <a:p>
-            <a:pPr indent="0" marL="0">
-              <a:lnSpc>
-                <a:spcPct val="100000"/>
-              </a:lnSpc>
-              <a:buNone/>
-            </a:pPr>
-            <a:r>
-              <a:rPr lang="en-US" sz="1250" b="1" dirty="0">
-                <a:solidFill>
-                  <a:srgbClr val="FFFFFF"/>
-                </a:solidFill>
-                <a:latin typeface="Arial" pitchFamily="34" charset="0"/>
-                <a:ea typeface="Arial" pitchFamily="34" charset="-122"/>
-                <a:cs typeface="Arial" pitchFamily="34" charset="-120"/>
-              </a:rPr>
-              <a:t>Peak Shaving (demanda contratada)</a:t>
-            </a:r>
-            <a:endParaRPr lang="en-US" sz="1250" dirty="0"/>
-          </a:p>
-        </p:txBody>
-      </p:sp>
-      <p:sp>
-        <p:nvSpPr>
-          <p:cNvPr id="7" name="Shape 5"/>
-          <p:cNvSpPr/>
-          <p:nvPr/>
-        </p:nvSpPr>
-        <p:spPr>
-          <a:xfrm>
-            <a:off x="685800" y="3328416"/>
-            <a:ext cx="4160520" cy="786384"/>
-          </a:xfrm>
-          <a:prstGeom prst="roundRect">
-            <a:avLst>
-              <a:gd name="adj" fmla="val 6977"/>
-            </a:avLst>
-          </a:prstGeom>
-          <a:solidFill>
-            <a:srgbClr val="7FB0CE"/>
-          </a:solidFill>
-          <a:ln/>
-          <a:effectLst>
-            <a:outerShdw sx="100000" sy="100000" kx="0" ky="0" algn="bl" rotWithShape="0" blurRad="88900" dist="25400" dir="5400000">
-              <a:srgbClr val="9AAAB4">
-                <a:alpha val="35000"/>
-              </a:srgbClr>
-            </a:outerShdw>
-          </a:effectLst>
-        </p:spPr>
-      </p:sp>
-      <p:sp>
-        <p:nvSpPr>
-          <p:cNvPr id="8" name="Text 6"/>
-          <p:cNvSpPr/>
-          <p:nvPr/>
-        </p:nvSpPr>
-        <p:spPr>
-          <a:xfrm>
-            <a:off x="886968" y="3328416"/>
-            <a:ext cx="3758184" cy="786384"/>
-          </a:xfrm>
-          <a:prstGeom prst="rect">
-            <a:avLst/>
-          </a:prstGeom>
-          <a:noFill/>
-          <a:ln/>
-        </p:spPr>
-        <p:txBody>
-          <a:bodyPr wrap="square" lIns="0" tIns="0" rIns="0" bIns="0" rtlCol="0" anchor="ctr"/>
-          <a:lstStyle/>
-          <a:p>
-            <a:pPr indent="0" marL="0">
-              <a:lnSpc>
-                <a:spcPct val="100000"/>
-              </a:lnSpc>
-              <a:buNone/>
-            </a:pPr>
-            <a:r>
-              <a:rPr lang="en-US" sz="1250" b="1" dirty="0">
-                <a:solidFill>
-                  <a:srgbClr val="102A3C"/>
-                </a:solidFill>
-                <a:latin typeface="Arial" pitchFamily="34" charset="0"/>
-                <a:ea typeface="Arial" pitchFamily="34" charset="-122"/>
-                <a:cs typeface="Arial" pitchFamily="34" charset="-120"/>
-              </a:rPr>
-              <a:t>Anti-curtailment (excedente FV)</a:t>
-            </a:r>
-            <a:endParaRPr lang="en-US" sz="1250" dirty="0"/>
-          </a:p>
-        </p:txBody>
-      </p:sp>
-      <p:sp>
-        <p:nvSpPr>
-          <p:cNvPr id="9" name="Shape 7"/>
-          <p:cNvSpPr/>
-          <p:nvPr/>
-        </p:nvSpPr>
-        <p:spPr>
-          <a:xfrm>
-            <a:off x="685800" y="2423160"/>
-            <a:ext cx="4160520" cy="786384"/>
-          </a:xfrm>
-          <a:prstGeom prst="roundRect">
-            <a:avLst>
-              <a:gd name="adj" fmla="val 6977"/>
-            </a:avLst>
-          </a:prstGeom>
-          <a:solidFill>
-            <a:srgbClr val="F2B705"/>
-          </a:solidFill>
-          <a:ln/>
-          <a:effectLst>
-            <a:outerShdw sx="100000" sy="100000" kx="0" ky="0" algn="bl" rotWithShape="0" blurRad="88900" dist="25400" dir="5400000">
-              <a:srgbClr val="9AAAB4">
-                <a:alpha val="35000"/>
-              </a:srgbClr>
-            </a:outerShdw>
-          </a:effectLst>
-        </p:spPr>
-      </p:sp>
-      <p:sp>
-        <p:nvSpPr>
-          <p:cNvPr id="10" name="Text 8"/>
-          <p:cNvSpPr/>
-          <p:nvPr/>
-        </p:nvSpPr>
-        <p:spPr>
-          <a:xfrm>
-            <a:off x="886968" y="2423160"/>
-            <a:ext cx="3758184" cy="786384"/>
-          </a:xfrm>
-          <a:prstGeom prst="rect">
-            <a:avLst/>
-          </a:prstGeom>
-          <a:noFill/>
-          <a:ln/>
-        </p:spPr>
-        <p:txBody>
-          <a:bodyPr wrap="square" lIns="0" tIns="0" rIns="0" bIns="0" rtlCol="0" anchor="ctr"/>
-          <a:lstStyle/>
-          <a:p>
-            <a:pPr indent="0" marL="0">
-              <a:lnSpc>
-                <a:spcPct val="100000"/>
-              </a:lnSpc>
-              <a:buNone/>
-            </a:pPr>
-            <a:r>
-              <a:rPr lang="en-US" sz="1250" b="1" dirty="0">
-                <a:solidFill>
-                  <a:srgbClr val="102A3C"/>
-                </a:solidFill>
-                <a:latin typeface="Arial" pitchFamily="34" charset="0"/>
-                <a:ea typeface="Arial" pitchFamily="34" charset="-122"/>
-                <a:cs typeface="Arial" pitchFamily="34" charset="-120"/>
-              </a:rPr>
-              <a:t>Créditos de GD / Geração Compartilhada</a:t>
-            </a:r>
-            <a:endParaRPr lang="en-US" sz="1250" dirty="0"/>
-          </a:p>
-        </p:txBody>
-      </p:sp>
-      <p:sp>
-        <p:nvSpPr>
-          <p:cNvPr id="11" name="Shape 9"/>
-          <p:cNvSpPr/>
-          <p:nvPr/>
-        </p:nvSpPr>
-        <p:spPr>
-          <a:xfrm>
-            <a:off x="5010912" y="2423160"/>
-            <a:ext cx="384048" cy="3502152"/>
-          </a:xfrm>
-          <a:prstGeom prst="upArrow">
-            <a:avLst/>
-          </a:prstGeom>
-          <a:solidFill>
-            <a:srgbClr val="EAF1F6"/>
-          </a:solidFill>
-          <a:ln w="9525">
-            <a:solidFill>
-              <a:srgbClr val="D9E2E8"/>
-            </a:solidFill>
-            <a:prstDash val="solid"/>
-          </a:ln>
-        </p:spPr>
-      </p:sp>
-      <p:sp>
-        <p:nvSpPr>
-          <p:cNvPr id="12" name="Text 10"/>
-          <p:cNvSpPr/>
-          <p:nvPr/>
-        </p:nvSpPr>
-        <p:spPr>
-          <a:xfrm>
-            <a:off x="685800" y="1536192"/>
-            <a:ext cx="4160520" cy="292608"/>
-          </a:xfrm>
-          <a:prstGeom prst="rect">
-            <a:avLst/>
-          </a:prstGeom>
-          <a:noFill/>
-          <a:ln/>
-        </p:spPr>
-        <p:txBody>
-          <a:bodyPr wrap="square" lIns="0" tIns="0" rIns="0" bIns="0" rtlCol="0" anchor="ctr"/>
-          <a:lstStyle/>
-          <a:p>
-            <a:pPr indent="0" marL="0">
-              <a:buNone/>
-            </a:pPr>
-            <a:r>
-              <a:rPr lang="en-US" sz="1050" b="1" spc="200" kern="0" dirty="0">
-                <a:solidFill>
-                  <a:srgbClr val="B78A00"/>
-                </a:solidFill>
-                <a:latin typeface="Arial" pitchFamily="34" charset="0"/>
-                <a:ea typeface="Arial" pitchFamily="34" charset="-122"/>
-                <a:cs typeface="Arial" pitchFamily="34" charset="-120"/>
-              </a:rPr>
-              <a:t>RECEITA ANUAL EMPILHADA</a:t>
-            </a:r>
-            <a:endParaRPr lang="en-US" sz="1050" dirty="0"/>
-          </a:p>
-        </p:txBody>
-      </p:sp>
-      <p:sp>
-        <p:nvSpPr>
-          <p:cNvPr id="13" name="Text 11"/>
+      <p:pic>
+        <p:nvPicPr>
+          <p:cNvPr id="3" name="Image 0" descr="stack.png">    </p:cNvPr>
+          <p:cNvPicPr>
+            <a:picLocks noChangeAspect="1"/>
+          </p:cNvPicPr>
+          <p:nvPr/>
+        </p:nvPicPr>
+        <p:blipFill>
+          <a:blip r:embed="rId1"/>
+          <a:stretch>
+            <a:fillRect/>
+          </a:stretch>
+        </p:blipFill>
+        <p:spPr>
+          <a:xfrm>
+            <a:off x="594360" y="1463040"/>
+            <a:ext cx="4663440" cy="4114800"/>
+          </a:xfrm>
+          <a:prstGeom prst="rect">
+            <a:avLst/>
+          </a:prstGeom>
+        </p:spPr>
+      </p:pic>
+      <p:sp>
+        <p:nvSpPr>
+          <p:cNvPr id="4" name="Text 1"/>
           <p:cNvSpPr/>
           <p:nvPr/>
         </p:nvSpPr>
@@ -9890,7 +9566,7 @@
       </p:sp>
       <p:sp>
         <p:nvSpPr>
-          <p:cNvPr id="14" name="Shape 12"/>
+          <p:cNvPr id="5" name="Shape 2"/>
           <p:cNvSpPr/>
           <p:nvPr/>
         </p:nvSpPr>
@@ -9912,7 +9588,7 @@
       </p:sp>
       <p:sp>
         <p:nvSpPr>
-          <p:cNvPr id="15" name="Text 13"/>
+          <p:cNvPr id="6" name="Text 3"/>
           <p:cNvSpPr/>
           <p:nvPr/>
         </p:nvSpPr>
@@ -9974,7 +9650,7 @@
       </p:sp>
       <p:sp>
         <p:nvSpPr>
-          <p:cNvPr id="16" name="Shape 14"/>
+          <p:cNvPr id="7" name="Shape 4"/>
           <p:cNvSpPr/>
           <p:nvPr/>
         </p:nvSpPr>
@@ -9996,7 +9672,7 @@
       </p:sp>
       <p:sp>
         <p:nvSpPr>
-          <p:cNvPr id="17" name="Text 15"/>
+          <p:cNvPr id="8" name="Text 5"/>
           <p:cNvSpPr/>
           <p:nvPr/>
         </p:nvSpPr>
@@ -10058,7 +9734,7 @@
       </p:sp>
       <p:sp>
         <p:nvSpPr>
-          <p:cNvPr id="18" name="Shape 16"/>
+          <p:cNvPr id="9" name="Shape 6"/>
           <p:cNvSpPr/>
           <p:nvPr/>
         </p:nvSpPr>
@@ -10080,7 +9756,7 @@
       </p:sp>
       <p:sp>
         <p:nvSpPr>
-          <p:cNvPr id="19" name="Text 17"/>
+          <p:cNvPr id="10" name="Text 7"/>
           <p:cNvSpPr/>
           <p:nvPr/>
         </p:nvSpPr>
@@ -10142,7 +9818,7 @@
       </p:sp>
       <p:sp>
         <p:nvSpPr>
-          <p:cNvPr id="20" name="Shape 18"/>
+          <p:cNvPr id="11" name="Shape 8"/>
           <p:cNvSpPr/>
           <p:nvPr/>
         </p:nvSpPr>
@@ -10164,7 +9840,7 @@
       </p:sp>
       <p:sp>
         <p:nvSpPr>
-          <p:cNvPr id="21" name="Text 19"/>
+          <p:cNvPr id="12" name="Text 9"/>
           <p:cNvSpPr/>
           <p:nvPr/>
         </p:nvSpPr>
@@ -10226,7 +9902,7 @@
       </p:sp>
       <p:sp>
         <p:nvSpPr>
-          <p:cNvPr id="22" name="Shape 20"/>
+          <p:cNvPr id="13" name="Shape 10"/>
           <p:cNvSpPr/>
           <p:nvPr/>
         </p:nvSpPr>
@@ -10248,7 +9924,7 @@
       </p:sp>
       <p:sp>
         <p:nvSpPr>
-          <p:cNvPr id="23" name="Text 21"/>
+          <p:cNvPr id="14" name="Text 11"/>
           <p:cNvSpPr/>
           <p:nvPr/>
         </p:nvSpPr>
@@ -10301,7 +9977,7 @@
       </p:sp>
       <p:sp>
         <p:nvSpPr>
-          <p:cNvPr id="25" name="Text 22"/>
+          <p:cNvPr id="16" name="Text 12"/>
           <p:cNvSpPr/>
           <p:nvPr/>
         </p:nvSpPr>
@@ -10340,7 +10016,7 @@
       </p:sp>
       <p:sp>
         <p:nvSpPr>
-          <p:cNvPr id="26" name="Text 23"/>
+          <p:cNvPr id="17" name="Text 13"/>
           <p:cNvSpPr/>
           <p:nvPr/>
         </p:nvSpPr>

</xml_diff>